<commit_message>
update chapter 7 notes
</commit_message>
<xml_diff>
--- a/lecture_notes/chapter7/chapter7.pptx
+++ b/lecture_notes/chapter7/chapter7.pptx
@@ -778,10 +778,25 @@
   <pc:docChgLst>
     <pc:chgData name="Toby Donaldson" userId="2e6e5431-bb17-4c41-9985-d39c50d83c73" providerId="ADAL" clId="{7F9681A8-EEE2-56F4-9B39-ECCBEE0471AC}"/>
     <pc:docChg chg="custSel addSld modSld sldOrd modSection">
-      <pc:chgData name="Toby Donaldson" userId="2e6e5431-bb17-4c41-9985-d39c50d83c73" providerId="ADAL" clId="{7F9681A8-EEE2-56F4-9B39-ECCBEE0471AC}" dt="2026-02-22T21:33:22.630" v="322" actId="5793"/>
+      <pc:chgData name="Toby Donaldson" userId="2e6e5431-bb17-4c41-9985-d39c50d83c73" providerId="ADAL" clId="{7F9681A8-EEE2-56F4-9B39-ECCBEE0471AC}" dt="2026-02-22T21:42:08.849" v="323" actId="113"/>
       <pc:docMkLst>
         <pc:docMk/>
       </pc:docMkLst>
+      <pc:sldChg chg="modSp mod">
+        <pc:chgData name="Toby Donaldson" userId="2e6e5431-bb17-4c41-9985-d39c50d83c73" providerId="ADAL" clId="{7F9681A8-EEE2-56F4-9B39-ECCBEE0471AC}" dt="2026-02-22T21:42:08.849" v="323" actId="113"/>
+        <pc:sldMkLst>
+          <pc:docMk/>
+          <pc:sldMk cId="2693912225" sldId="350"/>
+        </pc:sldMkLst>
+        <pc:spChg chg="mod">
+          <ac:chgData name="Toby Donaldson" userId="2e6e5431-bb17-4c41-9985-d39c50d83c73" providerId="ADAL" clId="{7F9681A8-EEE2-56F4-9B39-ECCBEE0471AC}" dt="2026-02-22T21:42:08.849" v="323" actId="113"/>
+          <ac:spMkLst>
+            <pc:docMk/>
+            <pc:sldMk cId="2693912225" sldId="350"/>
+            <ac:spMk id="41" creationId="{E5CBE02D-89B2-6D60-189D-FC0E58776964}"/>
+          </ac:spMkLst>
+        </pc:spChg>
+      </pc:sldChg>
       <pc:sldChg chg="delSp modSp mod">
         <pc:chgData name="Toby Donaldson" userId="2e6e5431-bb17-4c41-9985-d39c50d83c73" providerId="ADAL" clId="{7F9681A8-EEE2-56F4-9B39-ECCBEE0471AC}" dt="2026-02-22T21:19:22.515" v="218" actId="20577"/>
         <pc:sldMkLst>
@@ -11873,7 +11888,15 @@
             <a:pPr algn="ctr"/>
             <a:r>
               <a:rPr lang="en-CA" dirty="0"/>
-              <a:t>How many execution paths are there through this code?</a:t>
+              <a:t>How many </a:t>
+            </a:r>
+            <a:r>
+              <a:rPr lang="en-CA" b="1" dirty="0"/>
+              <a:t>execution paths </a:t>
+            </a:r>
+            <a:r>
+              <a:rPr lang="en-CA" dirty="0"/>
+              <a:t>are there through this code?</a:t>
             </a:r>
             <a:endParaRPr lang="en-AU" dirty="0"/>
           </a:p>

</xml_diff>